<commit_message>
docs: record approximate 430-student DTS cohort
</commit_message>
<xml_diff>
--- a/A1_Current/UUse_A1_6_Slides.pptx
+++ b/A1_Current/UUse_A1_6_Slides.pptx
@@ -2,18 +2,18 @@
 <file path=ppt/presentation.xml><?xml version="1.0" encoding="utf-8"?>
 <p:presentation xmlns:p="http://schemas.openxmlformats.org/presentationml/2006/main">
   <p:sldMasterIdLst>
-    <p:sldMasterId xmlns:r="http://schemas.openxmlformats.org/officeDocument/2006/relationships" id="2147483648" r:id="R6017096b5aa24f3d"/>
+    <p:sldMasterId xmlns:r="http://schemas.openxmlformats.org/officeDocument/2006/relationships" id="2147483648" r:id="Rb1ba777174f64ce8"/>
   </p:sldMasterIdLst>
   <p:notesMasterIdLst>
-    <p:notesMasterId xmlns:r="http://schemas.openxmlformats.org/officeDocument/2006/relationships" r:id="Rf78ad1f8880a4fd9"/>
+    <p:notesMasterId xmlns:r="http://schemas.openxmlformats.org/officeDocument/2006/relationships" r:id="R26afa793b8ee4d22"/>
   </p:notesMasterIdLst>
   <p:sldIdLst>
-    <p:sldId xmlns:r="http://schemas.openxmlformats.org/officeDocument/2006/relationships" id="256" r:id="R3d39cba8553a475b"/>
-    <p:sldId xmlns:r="http://schemas.openxmlformats.org/officeDocument/2006/relationships" id="257" r:id="R3fb10efd8c234b84"/>
-    <p:sldId xmlns:r="http://schemas.openxmlformats.org/officeDocument/2006/relationships" id="258" r:id="R79a81a3ae88947ca"/>
-    <p:sldId xmlns:r="http://schemas.openxmlformats.org/officeDocument/2006/relationships" id="259" r:id="Rdd987e874c3d4db8"/>
-    <p:sldId xmlns:r="http://schemas.openxmlformats.org/officeDocument/2006/relationships" id="260" r:id="Rc74abe09f7864bf2"/>
-    <p:sldId xmlns:r="http://schemas.openxmlformats.org/officeDocument/2006/relationships" id="261" r:id="R6978056c9b8c4652"/>
+    <p:sldId xmlns:r="http://schemas.openxmlformats.org/officeDocument/2006/relationships" id="256" r:id="R5ddc607951834325"/>
+    <p:sldId xmlns:r="http://schemas.openxmlformats.org/officeDocument/2006/relationships" id="257" r:id="Re73bea6826a54e8a"/>
+    <p:sldId xmlns:r="http://schemas.openxmlformats.org/officeDocument/2006/relationships" id="258" r:id="R1830d8f07b3e47ac"/>
+    <p:sldId xmlns:r="http://schemas.openxmlformats.org/officeDocument/2006/relationships" id="259" r:id="Re74f44e84370455d"/>
+    <p:sldId xmlns:r="http://schemas.openxmlformats.org/officeDocument/2006/relationships" id="260" r:id="Rae03b81d8bff474f"/>
+    <p:sldId xmlns:r="http://schemas.openxmlformats.org/officeDocument/2006/relationships" id="261" r:id="Rd6fab8b2ccbe4bb1"/>
   </p:sldIdLst>
   <p:sldSz cx="12192000" cy="6858000"/>
   <p:notesSz cx="6858000" cy="9144000"/>
@@ -490,6 +490,11 @@
               <a:t>The code is suitable for course demonstrations and the next user-validation stage within the tested scope. This does not certify a public launch or universal absence of defects. Real school-email delivery, physical devices, Safari and other browsers, actual campus GPS/network conditions, and the project's production environment and recovery remain to be accepted.</a:t>
             </a:r>
           </a:p>
+          <a:p xmlns:a="http://schemas.openxmlformats.org/drawingml/2006/main">
+            <a:r>
+              <a:t>Cohort update: Rita, 19 October 2026: approximately 430 students in the eight DTS classes. Team-reported cohort population, not measured demand, recruitment permission, invitations sent or active users. Individual class counts have not been supplied.</a:t>
+            </a:r>
+          </a:p>
         </p:txBody>
       </p:sp>
       <p:sp>
@@ -647,7 +652,7 @@
           </a:p>
           <a:p xmlns:a="http://schemas.openxmlformats.org/drawingml/2006/main">
             <a:r>
-              <a:t>Provisional SAM is the sum of eligible students in the eight DTS classes the team intends to reach, after verifying class sizes, channel permission and deduplication. No total headcount is invented. No national money TAM is claimed.</a:t>
+              <a:t>The pilot SAM boundary is approximately 430 students across the eight DTS classes, as reported by Rita on 19 October 2026. This is a cohort population estimate, not evidence that all students are reachable, interested, registered or active. Recruitment channel permission still needs confirmation. No individual class counts are invented. No national money TAM is claimed.</a:t>
             </a:r>
           </a:p>
           <a:p xmlns:a="http://schemas.openxmlformats.org/drawingml/2006/main">
@@ -657,7 +662,7 @@
           </a:p>
           <a:p xmlns:a="http://schemas.openxmlformats.org/drawingml/2006/main">
             <a:r>
-              <a:t>SOM here means two served requesters in four weeks, not two paying subscribers. The workbook shows the calculation and leaves class headcounts blank.</a:t>
+              <a:t>SOM here means two served requesters in four weeks, not two paying subscribers. The workbook records the reported aggregate as 430 in B35 and keeps the optional individual class breakdown blank. The 80 invitations, 10% posting and 25% completion remain planning assumptions. The cohort total does not increase the forecast or demonstrate demand.</a:t>
             </a:r>
           </a:p>
           <a:p xmlns:a="http://schemas.openxmlformats.org/drawingml/2006/main">
@@ -688,6 +693,11 @@
           <a:p xmlns:a="http://schemas.openxmlformats.org/drawingml/2006/main">
             <a:r>
               <a:t>New planning assumptions for this A1 edition. Four-week pilot: 80 potential requester invites, 10% posting, 25% fulfilment, four responsive owners, two fulfilments per owner, 50% paid share and CNY20 paid consideration. No observed outcomes are implied.</a:t>
+            </a:r>
+          </a:p>
+          <a:p xmlns:a="http://schemas.openxmlformats.org/drawingml/2006/main">
+            <a:r>
+              <a:t>Cohort update: Rita, 19 October 2026: approximately 430 students in the eight DTS classes. Team-reported cohort population, not measured demand, recruitment permission, invitations sent or active users. Individual class counts have not been supplied.</a:t>
             </a:r>
           </a:p>
         </p:txBody>
@@ -982,7 +992,7 @@
           </a:p>
           <a:p xmlns:a="http://schemas.openxmlformats.org/drawingml/2006/main">
             <a:r>
-              <a:t>A proposed later four-week pilot targets two genuine completed requests without a severe privacy or loss incident. This is a learning gate, not completed traction, a handbook rule or proof of viability. The eight DTS classes are the recruitment boundary, with actual headcounts and permission still to confirm. Low use or inadequate supply may justify a manual bulletin.</a:t>
+              <a:t>A proposed later four-week pilot targets two genuine completed requests without a severe privacy or loss incident. This is a learning gate, not completed traction, a handbook rule or proof of viability. The eight DTS classes are the recruitment boundary, with approximately 430 students reported by Rita on 19 October and recruitment permission still to confirm. Low use or inadequate supply may justify a manual bulletin.</a:t>
             </a:r>
           </a:p>
           <a:p xmlns:a="http://schemas.openxmlformats.org/drawingml/2006/main">
@@ -1008,6 +1018,11 @@
           <a:p xmlns:a="http://schemas.openxmlformats.org/drawingml/2006/main">
             <a:r>
               <a:t>The code is suitable for course demonstrations and the next user-validation stage within the tested scope. This does not certify a public launch or universal absence of defects. Real school-email delivery, physical devices, Safari and other browsers, actual campus GPS/network conditions, and the project's production environment and recovery remain to be accepted.</a:t>
+            </a:r>
+          </a:p>
+          <a:p xmlns:a="http://schemas.openxmlformats.org/drawingml/2006/main">
+            <a:r>
+              <a:t>Cohort update: Rita, 19 October 2026: approximately 430 students in the eight DTS classes. Team-reported cohort population, not measured demand, recruitment permission, invitations sent or active users. Individual class counts have not been supplied.</a:t>
             </a:r>
           </a:p>
         </p:txBody>
@@ -3450,12 +3465,12 @@
   </p:cSld>
   <p:clrMap bg1="lt1" tx1="dk1" bg2="lt2" tx2="dk2" accent1="accent1" accent2="accent2" accent3="accent3" accent4="accent4" accent5="accent5" accent6="accent6" hlink="hlink" folHlink="folHlink"/>
   <p:sldLayoutIdLst>
-    <p:sldLayoutId xmlns:r="http://schemas.openxmlformats.org/officeDocument/2006/relationships" id="2147483649" r:id="R81d37cfcab744fee"/>
-    <p:sldLayoutId xmlns:r="http://schemas.openxmlformats.org/officeDocument/2006/relationships" id="2147483650" r:id="R49ee661213d9400e"/>
-    <p:sldLayoutId xmlns:r="http://schemas.openxmlformats.org/officeDocument/2006/relationships" id="2147483651" r:id="R246500799afd4184"/>
-    <p:sldLayoutId xmlns:r="http://schemas.openxmlformats.org/officeDocument/2006/relationships" id="2147483652" r:id="Rd2d3bd63f60148b1"/>
-    <p:sldLayoutId xmlns:r="http://schemas.openxmlformats.org/officeDocument/2006/relationships" id="2147483653" r:id="Re370411ee9cc422f"/>
-    <p:sldLayoutId xmlns:r="http://schemas.openxmlformats.org/officeDocument/2006/relationships" id="2147483654" r:id="R6c6a32f9b77b49cc"/>
+    <p:sldLayoutId xmlns:r="http://schemas.openxmlformats.org/officeDocument/2006/relationships" id="2147483649" r:id="R017b26c95430499e"/>
+    <p:sldLayoutId xmlns:r="http://schemas.openxmlformats.org/officeDocument/2006/relationships" id="2147483650" r:id="Rf51d11a8bc404d80"/>
+    <p:sldLayoutId xmlns:r="http://schemas.openxmlformats.org/officeDocument/2006/relationships" id="2147483651" r:id="R475856ee17644972"/>
+    <p:sldLayoutId xmlns:r="http://schemas.openxmlformats.org/officeDocument/2006/relationships" id="2147483652" r:id="R64dd4caccdb745ab"/>
+    <p:sldLayoutId xmlns:r="http://schemas.openxmlformats.org/officeDocument/2006/relationships" id="2147483653" r:id="R4eae135dd2094850"/>
+    <p:sldLayoutId xmlns:r="http://schemas.openxmlformats.org/officeDocument/2006/relationships" id="2147483654" r:id="Rdca1a09d9cee428e"/>
   </p:sldLayoutIdLst>
   <p:txStyles>
     <p:titleStyle>
@@ -5004,7 +5019,7 @@
                 <a:ea typeface="Arial"/>
                 <a:cs typeface="Arial"/>
               </a:rPr>
-              <a:t>Proposed first pilot: eight DTS classes</a:t>
+              <a:t>Proposed pilot: eight DTS classes (~430 students)</a:t>
             </a:r>
           </a:p>
         </p:txBody>
@@ -5182,7 +5197,7 @@
           <p:cNvPr id="8" name="">
             <a:extLst xmlns:a="http://schemas.openxmlformats.org/drawingml/2006/main">
               <a:ext uri="{FF2B5EF4-FFF2-40B4-BE49-F238E27FC236}">
-                <a16:creationId xmlns:a16="http://schemas.microsoft.com/office/drawing/2014/main" id="{A6722693-B7AB-4255-B01A-BA59BFF79CDA}"/>
+                <a16:creationId xmlns:a16="http://schemas.microsoft.com/office/drawing/2014/main" id="{ABDD1CC1-B46A-4456-A90F-47B2173B3E1D}"/>
               </a:ext>
             </a:extLst>
           </p:cNvPr>
@@ -5192,7 +5207,7 @@
           <p:nvPr/>
         </p:nvPicPr>
         <p:blipFill>
-          <a:blip xmlns:r="http://schemas.openxmlformats.org/officeDocument/2006/relationships" xmlns:a="http://schemas.openxmlformats.org/drawingml/2006/main" r:embed="R42c67f4cbd3d4bd8"/>
+          <a:blip xmlns:r="http://schemas.openxmlformats.org/officeDocument/2006/relationships" xmlns:a="http://schemas.openxmlformats.org/drawingml/2006/main" r:embed="Rb14a4becf3194beb"/>
           <a:stretch xmlns:a="http://schemas.openxmlformats.org/drawingml/2006/main"/>
         </p:blipFill>
         <p:spPr>
@@ -9698,7 +9713,7 @@
                 <a:ea typeface="Arial"/>
                 <a:cs typeface="Arial"/>
               </a:rPr>
-              <a:t>Pilot SAM</a:t>
+              <a:t>Pilot SAM boundary</a:t>
             </a:r>
           </a:p>
         </p:txBody>
@@ -9866,7 +9881,7 @@
                 <a:ea typeface="Arial"/>
                 <a:cs typeface="Arial"/>
               </a:rPr>
-              <a:t>Eight DTS classes</a:t>
+              <a:t>~430 students</a:t>
             </a:r>
           </a:p>
         </p:txBody>
@@ -10034,7 +10049,7 @@
                 <a:ea typeface="Arial"/>
                 <a:cs typeface="Arial"/>
               </a:rPr>
-              <a:t>Recruitment boundary. Eligible headcount and channel access to confirm.</a:t>
+              <a:t>Eight DTS classes. Team estimate, access to confirm.</a:t>
             </a:r>
           </a:p>
         </p:txBody>
@@ -10548,7 +10563,7 @@
           <p:cNvPr id="13" name="">
             <a:extLst xmlns:a="http://schemas.openxmlformats.org/drawingml/2006/main">
               <a:ext uri="{FF2B5EF4-FFF2-40B4-BE49-F238E27FC236}">
-                <a16:creationId xmlns:a16="http://schemas.microsoft.com/office/drawing/2014/main" id="{A58C775B-6F43-462F-92BD-550A1F3C86A5}"/>
+                <a16:creationId xmlns:a16="http://schemas.microsoft.com/office/drawing/2014/main" id="{D2822B23-59A1-41F9-970B-0551FAEF8833}"/>
               </a:ext>
             </a:extLst>
           </p:cNvPr>
@@ -11961,7 +11976,7 @@
           <p:cNvPr id="4" name="">
             <a:extLst xmlns:a="http://schemas.openxmlformats.org/drawingml/2006/main">
               <a:ext uri="{FF2B5EF4-FFF2-40B4-BE49-F238E27FC236}">
-                <a16:creationId xmlns:a16="http://schemas.microsoft.com/office/drawing/2014/main" id="{170F7586-B66B-4FC6-8598-02E6CD101B9E}"/>
+                <a16:creationId xmlns:a16="http://schemas.microsoft.com/office/drawing/2014/main" id="{7D84D5C7-29B2-4475-A1D2-5089C2080CE4}"/>
               </a:ext>
             </a:extLst>
           </p:cNvPr>
@@ -11971,7 +11986,7 @@
           <p:nvPr/>
         </p:nvPicPr>
         <p:blipFill>
-          <a:blip xmlns:r="http://schemas.openxmlformats.org/officeDocument/2006/relationships" xmlns:a="http://schemas.openxmlformats.org/drawingml/2006/main" r:embed="R6a7b84d509484f9b"/>
+          <a:blip xmlns:r="http://schemas.openxmlformats.org/officeDocument/2006/relationships" xmlns:a="http://schemas.openxmlformats.org/drawingml/2006/main" r:embed="Rcb9c792e71174092"/>
           <a:stretch xmlns:a="http://schemas.openxmlformats.org/drawingml/2006/main"/>
         </p:blipFill>
         <p:spPr>
@@ -12493,7 +12508,7 @@
           <p:cNvPr id="8" name="">
             <a:extLst xmlns:a="http://schemas.openxmlformats.org/drawingml/2006/main">
               <a:ext uri="{FF2B5EF4-FFF2-40B4-BE49-F238E27FC236}">
-                <a16:creationId xmlns:a16="http://schemas.microsoft.com/office/drawing/2014/main" id="{69FC507B-939F-44CA-9B00-503BEBD9B018}"/>
+                <a16:creationId xmlns:a16="http://schemas.microsoft.com/office/drawing/2014/main" id="{1D0DC0C4-95A8-4547-AC4D-A35881A301BD}"/>
               </a:ext>
             </a:extLst>
           </p:cNvPr>
@@ -13579,6 +13594,7 @@
               </a:defRPr>
             </a:defPPr>
             <a:lvl1pPr>
+              <a:buNone/>
               <a:defRPr sz="1875" b="1">
                 <a:solidFill>
                   <a:srgbClr val="20322B"/>
@@ -13589,6 +13605,7 @@
               </a:defRPr>
             </a:lvl1pPr>
             <a:lvl2pPr>
+              <a:buNone/>
               <a:defRPr sz="1875" b="1">
                 <a:solidFill>
                   <a:srgbClr val="20322B"/>
@@ -13599,6 +13616,7 @@
               </a:defRPr>
             </a:lvl2pPr>
             <a:lvl3pPr>
+              <a:buNone/>
               <a:defRPr sz="1875" b="1">
                 <a:solidFill>
                   <a:srgbClr val="20322B"/>
@@ -13609,6 +13627,7 @@
               </a:defRPr>
             </a:lvl3pPr>
             <a:lvl4pPr>
+              <a:buNone/>
               <a:defRPr sz="1875" b="1">
                 <a:solidFill>
                   <a:srgbClr val="20322B"/>
@@ -13619,6 +13638,7 @@
               </a:defRPr>
             </a:lvl4pPr>
             <a:lvl5pPr>
+              <a:buNone/>
               <a:defRPr sz="1875" b="1">
                 <a:solidFill>
                   <a:srgbClr val="20322B"/>
@@ -13629,6 +13649,7 @@
               </a:defRPr>
             </a:lvl5pPr>
             <a:lvl6pPr>
+              <a:buNone/>
               <a:defRPr sz="1875" b="1">
                 <a:solidFill>
                   <a:srgbClr val="20322B"/>
@@ -13639,6 +13660,7 @@
               </a:defRPr>
             </a:lvl6pPr>
             <a:lvl7pPr>
+              <a:buNone/>
               <a:defRPr sz="1875" b="1">
                 <a:solidFill>
                   <a:srgbClr val="20322B"/>
@@ -13649,6 +13671,7 @@
               </a:defRPr>
             </a:lvl7pPr>
             <a:lvl8pPr>
+              <a:buNone/>
               <a:defRPr sz="1875" b="1">
                 <a:solidFill>
                   <a:srgbClr val="20322B"/>
@@ -13659,6 +13682,7 @@
               </a:defRPr>
             </a:lvl8pPr>
             <a:lvl9pPr>
+              <a:buNone/>
               <a:defRPr sz="1875" b="1">
                 <a:solidFill>
                   <a:srgbClr val="20322B"/>
@@ -13671,6 +13695,7 @@
           </a:lstStyle>
           <a:p xmlns:a="http://schemas.openxmlformats.org/drawingml/2006/main">
             <a:pPr>
+              <a:buNone/>
               <a:defRPr sz="1875" b="1">
                 <a:solidFill>
                   <a:srgbClr val="20322B"/>
@@ -13737,6 +13762,7 @@
               </a:defRPr>
             </a:defPPr>
             <a:lvl1pPr>
+              <a:buNone/>
               <a:defRPr sz="1800" b="0">
                 <a:solidFill>
                   <a:srgbClr val="20322B"/>
@@ -13747,6 +13773,7 @@
               </a:defRPr>
             </a:lvl1pPr>
             <a:lvl2pPr>
+              <a:buNone/>
               <a:defRPr sz="1800" b="0">
                 <a:solidFill>
                   <a:srgbClr val="20322B"/>
@@ -13757,6 +13784,7 @@
               </a:defRPr>
             </a:lvl2pPr>
             <a:lvl3pPr>
+              <a:buNone/>
               <a:defRPr sz="1800" b="0">
                 <a:solidFill>
                   <a:srgbClr val="20322B"/>
@@ -13767,6 +13795,7 @@
               </a:defRPr>
             </a:lvl3pPr>
             <a:lvl4pPr>
+              <a:buNone/>
               <a:defRPr sz="1800" b="0">
                 <a:solidFill>
                   <a:srgbClr val="20322B"/>
@@ -13777,6 +13806,7 @@
               </a:defRPr>
             </a:lvl4pPr>
             <a:lvl5pPr>
+              <a:buNone/>
               <a:defRPr sz="1800" b="0">
                 <a:solidFill>
                   <a:srgbClr val="20322B"/>
@@ -13787,6 +13817,7 @@
               </a:defRPr>
             </a:lvl5pPr>
             <a:lvl6pPr>
+              <a:buNone/>
               <a:defRPr sz="1800" b="0">
                 <a:solidFill>
                   <a:srgbClr val="20322B"/>
@@ -13797,6 +13828,7 @@
               </a:defRPr>
             </a:lvl6pPr>
             <a:lvl7pPr>
+              <a:buNone/>
               <a:defRPr sz="1800" b="0">
                 <a:solidFill>
                   <a:srgbClr val="20322B"/>
@@ -13807,6 +13839,7 @@
               </a:defRPr>
             </a:lvl7pPr>
             <a:lvl8pPr>
+              <a:buNone/>
               <a:defRPr sz="1800" b="0">
                 <a:solidFill>
                   <a:srgbClr val="20322B"/>
@@ -13817,6 +13850,7 @@
               </a:defRPr>
             </a:lvl8pPr>
             <a:lvl9pPr>
+              <a:buNone/>
               <a:defRPr sz="1800" b="0">
                 <a:solidFill>
                   <a:srgbClr val="20322B"/>
@@ -13829,6 +13863,7 @@
           </a:lstStyle>
           <a:p xmlns:a="http://schemas.openxmlformats.org/drawingml/2006/main">
             <a:pPr>
+              <a:buNone/>
               <a:defRPr sz="1800" b="0">
                 <a:solidFill>
                   <a:srgbClr val="20322B"/>
@@ -13895,6 +13930,7 @@
               </a:defRPr>
             </a:defPPr>
             <a:lvl1pPr>
+              <a:buNone/>
               <a:defRPr sz="1875" b="1">
                 <a:solidFill>
                   <a:srgbClr val="20322B"/>
@@ -13905,6 +13941,7 @@
               </a:defRPr>
             </a:lvl1pPr>
             <a:lvl2pPr>
+              <a:buNone/>
               <a:defRPr sz="1875" b="1">
                 <a:solidFill>
                   <a:srgbClr val="20322B"/>
@@ -13915,6 +13952,7 @@
               </a:defRPr>
             </a:lvl2pPr>
             <a:lvl3pPr>
+              <a:buNone/>
               <a:defRPr sz="1875" b="1">
                 <a:solidFill>
                   <a:srgbClr val="20322B"/>
@@ -13925,6 +13963,7 @@
               </a:defRPr>
             </a:lvl3pPr>
             <a:lvl4pPr>
+              <a:buNone/>
               <a:defRPr sz="1875" b="1">
                 <a:solidFill>
                   <a:srgbClr val="20322B"/>
@@ -13935,6 +13974,7 @@
               </a:defRPr>
             </a:lvl4pPr>
             <a:lvl5pPr>
+              <a:buNone/>
               <a:defRPr sz="1875" b="1">
                 <a:solidFill>
                   <a:srgbClr val="20322B"/>
@@ -13945,6 +13985,7 @@
               </a:defRPr>
             </a:lvl5pPr>
             <a:lvl6pPr>
+              <a:buNone/>
               <a:defRPr sz="1875" b="1">
                 <a:solidFill>
                   <a:srgbClr val="20322B"/>
@@ -13955,6 +13996,7 @@
               </a:defRPr>
             </a:lvl6pPr>
             <a:lvl7pPr>
+              <a:buNone/>
               <a:defRPr sz="1875" b="1">
                 <a:solidFill>
                   <a:srgbClr val="20322B"/>
@@ -13965,6 +14007,7 @@
               </a:defRPr>
             </a:lvl7pPr>
             <a:lvl8pPr>
+              <a:buNone/>
               <a:defRPr sz="1875" b="1">
                 <a:solidFill>
                   <a:srgbClr val="20322B"/>
@@ -13975,6 +14018,7 @@
               </a:defRPr>
             </a:lvl8pPr>
             <a:lvl9pPr>
+              <a:buNone/>
               <a:defRPr sz="1875" b="1">
                 <a:solidFill>
                   <a:srgbClr val="20322B"/>
@@ -13987,6 +14031,7 @@
           </a:lstStyle>
           <a:p xmlns:a="http://schemas.openxmlformats.org/drawingml/2006/main">
             <a:pPr>
+              <a:buNone/>
               <a:defRPr sz="1875" b="1">
                 <a:solidFill>
                   <a:srgbClr val="20322B"/>
@@ -14053,6 +14098,7 @@
               </a:defRPr>
             </a:defPPr>
             <a:lvl1pPr>
+              <a:buNone/>
               <a:defRPr sz="1800" b="0">
                 <a:solidFill>
                   <a:srgbClr val="20322B"/>
@@ -14063,6 +14109,7 @@
               </a:defRPr>
             </a:lvl1pPr>
             <a:lvl2pPr>
+              <a:buNone/>
               <a:defRPr sz="1800" b="0">
                 <a:solidFill>
                   <a:srgbClr val="20322B"/>
@@ -14073,6 +14120,7 @@
               </a:defRPr>
             </a:lvl2pPr>
             <a:lvl3pPr>
+              <a:buNone/>
               <a:defRPr sz="1800" b="0">
                 <a:solidFill>
                   <a:srgbClr val="20322B"/>
@@ -14083,6 +14131,7 @@
               </a:defRPr>
             </a:lvl3pPr>
             <a:lvl4pPr>
+              <a:buNone/>
               <a:defRPr sz="1800" b="0">
                 <a:solidFill>
                   <a:srgbClr val="20322B"/>
@@ -14093,6 +14142,7 @@
               </a:defRPr>
             </a:lvl4pPr>
             <a:lvl5pPr>
+              <a:buNone/>
               <a:defRPr sz="1800" b="0">
                 <a:solidFill>
                   <a:srgbClr val="20322B"/>
@@ -14103,6 +14153,7 @@
               </a:defRPr>
             </a:lvl5pPr>
             <a:lvl6pPr>
+              <a:buNone/>
               <a:defRPr sz="1800" b="0">
                 <a:solidFill>
                   <a:srgbClr val="20322B"/>
@@ -14113,6 +14164,7 @@
               </a:defRPr>
             </a:lvl6pPr>
             <a:lvl7pPr>
+              <a:buNone/>
               <a:defRPr sz="1800" b="0">
                 <a:solidFill>
                   <a:srgbClr val="20322B"/>
@@ -14123,6 +14175,7 @@
               </a:defRPr>
             </a:lvl7pPr>
             <a:lvl8pPr>
+              <a:buNone/>
               <a:defRPr sz="1800" b="0">
                 <a:solidFill>
                   <a:srgbClr val="20322B"/>
@@ -14133,6 +14186,7 @@
               </a:defRPr>
             </a:lvl8pPr>
             <a:lvl9pPr>
+              <a:buNone/>
               <a:defRPr sz="1800" b="0">
                 <a:solidFill>
                   <a:srgbClr val="20322B"/>
@@ -14145,6 +14199,7 @@
           </a:lstStyle>
           <a:p xmlns:a="http://schemas.openxmlformats.org/drawingml/2006/main">
             <a:pPr>
+              <a:buNone/>
               <a:defRPr sz="1800" b="0">
                 <a:solidFill>
                   <a:srgbClr val="20322B"/>
@@ -14706,7 +14761,7 @@
           <p:cNvPr id="4" name="">
             <a:extLst xmlns:a="http://schemas.openxmlformats.org/drawingml/2006/main">
               <a:ext uri="{FF2B5EF4-FFF2-40B4-BE49-F238E27FC236}">
-                <a16:creationId xmlns:a16="http://schemas.microsoft.com/office/drawing/2014/main" id="{8698DA35-3A59-4919-AE95-905DD52FEFFD}"/>
+                <a16:creationId xmlns:a16="http://schemas.microsoft.com/office/drawing/2014/main" id="{E934265A-0EB1-435D-A1CE-75ED39E3B3DD}"/>
               </a:ext>
             </a:extLst>
           </p:cNvPr>

</xml_diff>

<commit_message>
docs: correct A1 market context to XEC campus population
</commit_message>
<xml_diff>
--- a/A1_Current/UUse_A1_6_Slides.pptx
+++ b/A1_Current/UUse_A1_6_Slides.pptx
@@ -2,18 +2,18 @@
 <file path=ppt/presentation.xml><?xml version="1.0" encoding="utf-8"?>
 <p:presentation xmlns:p="http://schemas.openxmlformats.org/presentationml/2006/main">
   <p:sldMasterIdLst>
-    <p:sldMasterId xmlns:r="http://schemas.openxmlformats.org/officeDocument/2006/relationships" id="2147483648" r:id="Rb1ba777174f64ce8"/>
+    <p:sldMasterId xmlns:r="http://schemas.openxmlformats.org/officeDocument/2006/relationships" id="2147483648" r:id="R3fe365bad1124b51"/>
   </p:sldMasterIdLst>
   <p:notesMasterIdLst>
-    <p:notesMasterId xmlns:r="http://schemas.openxmlformats.org/officeDocument/2006/relationships" r:id="R26afa793b8ee4d22"/>
+    <p:notesMasterId xmlns:r="http://schemas.openxmlformats.org/officeDocument/2006/relationships" r:id="R0202d7acb15f46a2"/>
   </p:notesMasterIdLst>
   <p:sldIdLst>
-    <p:sldId xmlns:r="http://schemas.openxmlformats.org/officeDocument/2006/relationships" id="256" r:id="R5ddc607951834325"/>
-    <p:sldId xmlns:r="http://schemas.openxmlformats.org/officeDocument/2006/relationships" id="257" r:id="Re73bea6826a54e8a"/>
-    <p:sldId xmlns:r="http://schemas.openxmlformats.org/officeDocument/2006/relationships" id="258" r:id="R1830d8f07b3e47ac"/>
-    <p:sldId xmlns:r="http://schemas.openxmlformats.org/officeDocument/2006/relationships" id="259" r:id="Re74f44e84370455d"/>
-    <p:sldId xmlns:r="http://schemas.openxmlformats.org/officeDocument/2006/relationships" id="260" r:id="Rae03b81d8bff474f"/>
-    <p:sldId xmlns:r="http://schemas.openxmlformats.org/officeDocument/2006/relationships" id="261" r:id="Rd6fab8b2ccbe4bb1"/>
+    <p:sldId xmlns:r="http://schemas.openxmlformats.org/officeDocument/2006/relationships" id="256" r:id="R6a06b2674d6b43a5"/>
+    <p:sldId xmlns:r="http://schemas.openxmlformats.org/officeDocument/2006/relationships" id="257" r:id="Rd2656085fc0e4e6e"/>
+    <p:sldId xmlns:r="http://schemas.openxmlformats.org/officeDocument/2006/relationships" id="258" r:id="R624d9159eaa443d1"/>
+    <p:sldId xmlns:r="http://schemas.openxmlformats.org/officeDocument/2006/relationships" id="259" r:id="R774974c74dcc475e"/>
+    <p:sldId xmlns:r="http://schemas.openxmlformats.org/officeDocument/2006/relationships" id="260" r:id="R1d073e70e4ba4de6"/>
+    <p:sldId xmlns:r="http://schemas.openxmlformats.org/officeDocument/2006/relationships" id="261" r:id="Ra081ca10e3b34f0c"/>
   </p:sldIdLst>
   <p:sldSz cx="12192000" cy="6858000"/>
   <p:notesSz cx="6858000" cy="9144000"/>
@@ -647,7 +647,7 @@
           <a:lstStyle xmlns:a="http://schemas.openxmlformats.org/drawingml/2006/main"/>
           <a:p xmlns:a="http://schemas.openxmlformats.org/drawingml/2006/main">
             <a:r>
-              <a:t>TAM is a broad institutional user universe, not an evidenced short-term rental demand estimate or monetised market. XJTLU reports 26,000+ students, updated May 2026. No assumption places all of them at XEC/SIP.</a:t>
+              <a:t>The broad population context is now campus-specific: a Xinhua Daily article republished on the XJTLU website in May 2026 reports more than 4,000 students at XEC (Taicang). This is a dated report, not an October 2026 administrative headcount, a measured number needing this service, or an active-user count. Population alone does not quantify item-access demand. We exclude the university-wide total from the pilot market sizing. SIP remains an interface option, not an additional population silently counted in this XEC-first pilot.</a:t>
             </a:r>
           </a:p>
           <a:p xmlns:a="http://schemas.openxmlformats.org/drawingml/2006/main">
@@ -672,7 +672,7 @@
           </a:p>
           <a:p xmlns:a="http://schemas.openxmlformats.org/drawingml/2006/main">
             <a:r>
-              <a:t>XJTLU Overview &amp; Key Facts. https://www.xjtlu.edu.cn/en/overview . Accessed 15 October 2026. Institutional figure updated May 2026.</a:t>
+              <a:t>S1. Xinhua Daily article republished on XJTLU's official website in May 2026, reporting more than 4,000 enrolled students at XJTLU Entrepreneur College (Taicang). Accessed 19 October 2026 through the indexed university-hosted article. https://www.xjtlu.edu.cn/zh/news/2026/05/xinhuaribao20zhounianxinwen . This is dated media context, not an October enrolment register or measured demand.</a:t>
             </a:r>
           </a:p>
           <a:p xmlns:a="http://schemas.openxmlformats.org/drawingml/2006/main">
@@ -3465,12 +3465,12 @@
   </p:cSld>
   <p:clrMap bg1="lt1" tx1="dk1" bg2="lt2" tx2="dk2" accent1="accent1" accent2="accent2" accent3="accent3" accent4="accent4" accent5="accent5" accent6="accent6" hlink="hlink" folHlink="folHlink"/>
   <p:sldLayoutIdLst>
-    <p:sldLayoutId xmlns:r="http://schemas.openxmlformats.org/officeDocument/2006/relationships" id="2147483649" r:id="R017b26c95430499e"/>
-    <p:sldLayoutId xmlns:r="http://schemas.openxmlformats.org/officeDocument/2006/relationships" id="2147483650" r:id="Rf51d11a8bc404d80"/>
-    <p:sldLayoutId xmlns:r="http://schemas.openxmlformats.org/officeDocument/2006/relationships" id="2147483651" r:id="R475856ee17644972"/>
-    <p:sldLayoutId xmlns:r="http://schemas.openxmlformats.org/officeDocument/2006/relationships" id="2147483652" r:id="R64dd4caccdb745ab"/>
-    <p:sldLayoutId xmlns:r="http://schemas.openxmlformats.org/officeDocument/2006/relationships" id="2147483653" r:id="R4eae135dd2094850"/>
-    <p:sldLayoutId xmlns:r="http://schemas.openxmlformats.org/officeDocument/2006/relationships" id="2147483654" r:id="Rdca1a09d9cee428e"/>
+    <p:sldLayoutId xmlns:r="http://schemas.openxmlformats.org/officeDocument/2006/relationships" id="2147483649" r:id="R36e8eff044fe4a44"/>
+    <p:sldLayoutId xmlns:r="http://schemas.openxmlformats.org/officeDocument/2006/relationships" id="2147483650" r:id="Re3c902fa980447db"/>
+    <p:sldLayoutId xmlns:r="http://schemas.openxmlformats.org/officeDocument/2006/relationships" id="2147483651" r:id="R8f698806249741a4"/>
+    <p:sldLayoutId xmlns:r="http://schemas.openxmlformats.org/officeDocument/2006/relationships" id="2147483652" r:id="R100a79ed7a2e4a0a"/>
+    <p:sldLayoutId xmlns:r="http://schemas.openxmlformats.org/officeDocument/2006/relationships" id="2147483653" r:id="R8b37419a0c2f49f2"/>
+    <p:sldLayoutId xmlns:r="http://schemas.openxmlformats.org/officeDocument/2006/relationships" id="2147483654" r:id="Rd935f3d0e8f74c5f"/>
   </p:sldLayoutIdLst>
   <p:txStyles>
     <p:titleStyle>
@@ -5197,7 +5197,7 @@
           <p:cNvPr id="8" name="">
             <a:extLst xmlns:a="http://schemas.openxmlformats.org/drawingml/2006/main">
               <a:ext uri="{FF2B5EF4-FFF2-40B4-BE49-F238E27FC236}">
-                <a16:creationId xmlns:a16="http://schemas.microsoft.com/office/drawing/2014/main" id="{ABDD1CC1-B46A-4456-A90F-47B2173B3E1D}"/>
+                <a16:creationId xmlns:a16="http://schemas.microsoft.com/office/drawing/2014/main" id="{44253144-7BD0-4625-84E7-65852FA861FB}"/>
               </a:ext>
             </a:extLst>
           </p:cNvPr>
@@ -5207,7 +5207,7 @@
           <p:nvPr/>
         </p:nvPicPr>
         <p:blipFill>
-          <a:blip xmlns:r="http://schemas.openxmlformats.org/officeDocument/2006/relationships" xmlns:a="http://schemas.openxmlformats.org/drawingml/2006/main" r:embed="Rb14a4becf3194beb"/>
+          <a:blip xmlns:r="http://schemas.openxmlformats.org/officeDocument/2006/relationships" xmlns:a="http://schemas.openxmlformats.org/drawingml/2006/main" r:embed="Rbc81d4032da645c7"/>
           <a:stretch xmlns:a="http://schemas.openxmlformats.org/drawingml/2006/main"/>
         </p:blipFill>
         <p:spPr>
@@ -9209,7 +9209,7 @@
                 <a:ea typeface="Arial"/>
                 <a:cs typeface="Arial"/>
               </a:rPr>
-              <a:t>TAM context</a:t>
+              <a:t>TAM context (XEC)</a:t>
             </a:r>
           </a:p>
         </p:txBody>
@@ -9377,7 +9377,7 @@
                 <a:ea typeface="Arial"/>
                 <a:cs typeface="Arial"/>
               </a:rPr>
-              <a:t>26,000+ students</a:t>
+              <a:t>4,000+ students</a:t>
             </a:r>
           </a:p>
         </p:txBody>
@@ -9545,7 +9545,7 @@
                 <a:ea typeface="Arial"/>
                 <a:cs typeface="Arial"/>
               </a:rPr>
-              <a:t>Institution-wide universe. Local demand is unmeasured.</a:t>
+              <a:t>XEC only, May 2026 report. Demand remains unmeasured.</a:t>
             </a:r>
           </a:p>
         </p:txBody>
@@ -10563,7 +10563,7 @@
           <p:cNvPr id="13" name="">
             <a:extLst xmlns:a="http://schemas.openxmlformats.org/drawingml/2006/main">
               <a:ext uri="{FF2B5EF4-FFF2-40B4-BE49-F238E27FC236}">
-                <a16:creationId xmlns:a16="http://schemas.microsoft.com/office/drawing/2014/main" id="{D2822B23-59A1-41F9-970B-0551FAEF8833}"/>
+                <a16:creationId xmlns:a16="http://schemas.microsoft.com/office/drawing/2014/main" id="{EC2D820E-8247-4853-AA92-E4BCA4FBE973}"/>
               </a:ext>
             </a:extLst>
           </p:cNvPr>
@@ -11976,7 +11976,7 @@
           <p:cNvPr id="4" name="">
             <a:extLst xmlns:a="http://schemas.openxmlformats.org/drawingml/2006/main">
               <a:ext uri="{FF2B5EF4-FFF2-40B4-BE49-F238E27FC236}">
-                <a16:creationId xmlns:a16="http://schemas.microsoft.com/office/drawing/2014/main" id="{7D84D5C7-29B2-4475-A1D2-5089C2080CE4}"/>
+                <a16:creationId xmlns:a16="http://schemas.microsoft.com/office/drawing/2014/main" id="{4E22C8C2-5AAD-4167-B04A-5B4F00E7F9A2}"/>
               </a:ext>
             </a:extLst>
           </p:cNvPr>
@@ -11986,7 +11986,7 @@
           <p:nvPr/>
         </p:nvPicPr>
         <p:blipFill>
-          <a:blip xmlns:r="http://schemas.openxmlformats.org/officeDocument/2006/relationships" xmlns:a="http://schemas.openxmlformats.org/drawingml/2006/main" r:embed="Rcb9c792e71174092"/>
+          <a:blip xmlns:r="http://schemas.openxmlformats.org/officeDocument/2006/relationships" xmlns:a="http://schemas.openxmlformats.org/drawingml/2006/main" r:embed="R495e481ab2bf45fa"/>
           <a:stretch xmlns:a="http://schemas.openxmlformats.org/drawingml/2006/main"/>
         </p:blipFill>
         <p:spPr>
@@ -12508,7 +12508,7 @@
           <p:cNvPr id="8" name="">
             <a:extLst xmlns:a="http://schemas.openxmlformats.org/drawingml/2006/main">
               <a:ext uri="{FF2B5EF4-FFF2-40B4-BE49-F238E27FC236}">
-                <a16:creationId xmlns:a16="http://schemas.microsoft.com/office/drawing/2014/main" id="{1D0DC0C4-95A8-4547-AC4D-A35881A301BD}"/>
+                <a16:creationId xmlns:a16="http://schemas.microsoft.com/office/drawing/2014/main" id="{5DDEAB1E-08E0-440B-BDC2-56A1C579979A}"/>
               </a:ext>
             </a:extLst>
           </p:cNvPr>
@@ -14761,7 +14761,7 @@
           <p:cNvPr id="4" name="">
             <a:extLst xmlns:a="http://schemas.openxmlformats.org/drawingml/2006/main">
               <a:ext uri="{FF2B5EF4-FFF2-40B4-BE49-F238E27FC236}">
-                <a16:creationId xmlns:a16="http://schemas.microsoft.com/office/drawing/2014/main" id="{E934265A-0EB1-435D-A1CE-75ED39E3B3DD}"/>
+                <a16:creationId xmlns:a16="http://schemas.microsoft.com/office/drawing/2014/main" id="{53A2B7DA-5BC6-488F-BE44-84B21D54341F}"/>
               </a:ext>
             </a:extLst>
           </p:cNvPr>

</xml_diff>